<commit_message>
Translate slide content to Korean
Co-Authored-By: Claude Opus 4.6 <noreply@anthropic.com>
</commit_message>
<xml_diff>
--- a/docs/euAIKG_technical.pptx
+++ b/docs/euAIKG_technical.pptx
@@ -3131,7 +3131,7 @@
               </a:defRPr>
             </a:pPr>
             <a:r>
-              <a:t>System Architecture</a:t>
+              <a:t>시스템 아키텍처</a:t>
             </a:r>
           </a:p>
         </p:txBody>
@@ -3169,7 +3169,7 @@
               </a:defRPr>
             </a:pPr>
             <a:r>
-              <a:t>EU AI Act Text -&gt; LLM Graph Extraction -&gt; Neo4j -&gt; Web Dashboard</a:t>
+              <a:t>EU AI Act 원문 -&gt; LLM 기반 그래프 추출 -&gt; Neo4j 저장 -&gt; 웹 대시보드 시각화</a:t>
             </a:r>
           </a:p>
           <a:p>
@@ -3196,7 +3196,7 @@
               </a:defRPr>
             </a:pPr>
             <a:r>
-              <a:t>- Backend: Neo4j (Graph DB) + vLLM / Gemini API (Compute Engine)</a:t>
+              <a:t>- 백엔드: Neo4j (그래프 DB) + vLLM / Gemini API (계산엔진)</a:t>
             </a:r>
           </a:p>
           <a:p>
@@ -3211,7 +3211,7 @@
               </a:defRPr>
             </a:pPr>
             <a:r>
-              <a:t>- Frontend: Flask + Cytoscape.js (Single Page Dashboard)</a:t>
+              <a:t>- 프론트엔드: Flask + Cytoscape.js (단일 페이지 대시보드)</a:t>
             </a:r>
           </a:p>
           <a:p>
@@ -3226,7 +3226,7 @@
               </a:defRPr>
             </a:pPr>
             <a:r>
-              <a:t>- Resumable pipeline with CLI / Web dual execution mode</a:t>
+              <a:t>- 재개 가능한 파이프라인, CLI / 웹 이중 실행 모드 지원</a:t>
             </a:r>
           </a:p>
         </p:txBody>
@@ -3311,7 +3311,7 @@
               </a:defRPr>
             </a:pPr>
             <a:r>
-              <a:t>Design Principles</a:t>
+              <a:t>설계 원칙</a:t>
             </a:r>
           </a:p>
         </p:txBody>
@@ -3390,7 +3390,7 @@
               </a:defRPr>
             </a:pPr>
             <a:r>
-              <a:t>1. Dual-LLM Robustness</a:t>
+              <a:t>1. 이중 LLM 견고성</a:t>
             </a:r>
           </a:p>
         </p:txBody>
@@ -3428,7 +3428,7 @@
               </a:defRPr>
             </a:pPr>
             <a:r>
-              <a:t>Local vLLM for throughput, Gemini API fallback for failed chunks</a:t>
+              <a:t>로컬 vLLM으로 처리량 확보, 실패 청크만 Gemini API로 재시도</a:t>
             </a:r>
           </a:p>
           <a:p>
@@ -3443,7 +3443,7 @@
               </a:defRPr>
             </a:pPr>
             <a:r>
-              <a:t>-&gt; Cost efficiency + extraction completeness</a:t>
+              <a:t>-&gt; 비용 효율성 + 추출 완성도 동시 달성</a:t>
             </a:r>
           </a:p>
         </p:txBody>
@@ -3522,7 +3522,7 @@
               </a:defRPr>
             </a:pPr>
             <a:r>
-              <a:t>2. Graph-Native Storage</a:t>
+              <a:t>2. 그래프 네이티브 저장</a:t>
             </a:r>
           </a:p>
         </p:txBody>
@@ -3560,7 +3560,7 @@
               </a:defRPr>
             </a:pPr>
             <a:r>
-              <a:t>Entity relationships as first-class citizens in Neo4j</a:t>
+              <a:t>엔티티 간 관계를 Neo4j에서 1차 시민(first-class)으로 표현</a:t>
             </a:r>
           </a:p>
           <a:p>
@@ -3575,7 +3575,7 @@
               </a:defRPr>
             </a:pPr>
             <a:r>
-              <a:t>Native graph algorithms (KNN, WCC) via GDS plugin</a:t>
+              <a:t>GDS 플러그인을 통한 네이티브 그래프 알고리즘(KNN, WCC) 적용</a:t>
             </a:r>
           </a:p>
         </p:txBody>
@@ -3654,7 +3654,7 @@
               </a:defRPr>
             </a:pPr>
             <a:r>
-              <a:t>3. LLM-Assisted Entity Resolution</a:t>
+              <a:t>3. LLM 기반 엔티티 해소</a:t>
             </a:r>
           </a:p>
         </p:txBody>
@@ -3692,7 +3692,7 @@
               </a:defRPr>
             </a:pPr>
             <a:r>
-              <a:t>Embedding similarity + text distance for candidate narrowing</a:t>
+              <a:t>임베딩 유사도 + 텍스트 거리로 후보군 축소</a:t>
             </a:r>
           </a:p>
           <a:p>
@@ -3707,7 +3707,7 @@
               </a:defRPr>
             </a:pPr>
             <a:r>
-              <a:t>Gemini structured output for final merge judgment</a:t>
+              <a:t>Gemini 구조화 출력으로 최종 병합 판정</a:t>
             </a:r>
           </a:p>
         </p:txBody>
@@ -3786,7 +3786,7 @@
               </a:defRPr>
             </a:pPr>
             <a:r>
-              <a:t>4. Resumable Pipeline</a:t>
+              <a:t>4. 재개 가능한 파이프라인</a:t>
             </a:r>
           </a:p>
         </p:txBody>
@@ -3824,7 +3824,7 @@
               </a:defRPr>
             </a:pPr>
             <a:r>
-              <a:t>Checkpoint per phase (pickle existence, node count, WCC property)</a:t>
+              <a:t>단계별 체크포인트(pickle 존재, 노드 수, WCC 속성) 확인</a:t>
             </a:r>
           </a:p>
           <a:p>
@@ -3839,7 +3839,7 @@
               </a:defRPr>
             </a:pPr>
             <a:r>
-              <a:t>Resume after interruption without reprocessing</a:t>
+              <a:t>중단 후 재처리 없이 이어서 실행 가능</a:t>
             </a:r>
           </a:p>
         </p:txBody>
@@ -3900,7 +3900,7 @@
               </a:defRPr>
             </a:pPr>
             <a:r>
-              <a:t>Methodology — Graph Extraction &amp; Ingestion</a:t>
+              <a:t>방법론 — 그래프 추출 및 적재</a:t>
             </a:r>
           </a:p>
         </p:txBody>
@@ -3938,7 +3938,7 @@
               </a:defRPr>
             </a:pPr>
             <a:r>
-              <a:t>Graph Extraction</a:t>
+              <a:t>그래프 추출</a:t>
             </a:r>
           </a:p>
           <a:p>
@@ -3953,7 +3953,7 @@
               </a:defRPr>
             </a:pPr>
             <a:r>
-              <a:t>  - LLMGraphTransformer: auto-extract entities &amp; relations from text chunks</a:t>
+              <a:t>  - LLMGraphTransformer로 텍스트 청크에서 엔티티·관계 자동 추출</a:t>
             </a:r>
           </a:p>
           <a:p>
@@ -3968,7 +3968,7 @@
               </a:defRPr>
             </a:pPr>
             <a:r>
-              <a:t>  - 4-thread parallel, 300s timeout per chunk</a:t>
+              <a:t>  - 4스레드 병렬 처리, 청크당 300초 타임아웃</a:t>
             </a:r>
           </a:p>
           <a:p>
@@ -3983,7 +3983,7 @@
               </a:defRPr>
             </a:pPr>
             <a:r>
-              <a:t>  - vLLM (Qwen3-14B-AWQ) primary + Gemini API fallback</a:t>
+              <a:t>  - vLLM (Qwen3-14B-AWQ) 1차 추출 + Gemini API 2차 폴백</a:t>
             </a:r>
           </a:p>
           <a:p>
@@ -4010,7 +4010,7 @@
               </a:defRPr>
             </a:pPr>
             <a:r>
-              <a:t>Ingestion</a:t>
+              <a:t>적재</a:t>
             </a:r>
           </a:p>
           <a:p>
@@ -4025,7 +4025,7 @@
               </a:defRPr>
             </a:pPr>
             <a:r>
-              <a:t>  - Deserialized GraphDocuments bulk-loaded into Neo4j</a:t>
+              <a:t>  - 역직렬화된 GraphDocument를 Neo4j에 일괄 적재</a:t>
             </a:r>
           </a:p>
           <a:p>
@@ -4040,7 +4040,7 @@
               </a:defRPr>
             </a:pPr>
             <a:r>
-              <a:t>  - __Entity__ common label + MENTIONS source reference</a:t>
+              <a:t>  - __Entity__ 공통 레이블 부여, MENTIONS 원문 참조 관계 생성</a:t>
             </a:r>
           </a:p>
         </p:txBody>
@@ -4125,7 +4125,7 @@
               </a:defRPr>
             </a:pPr>
             <a:r>
-              <a:t>Methodology — Community Detection &amp; Entity Resolution</a:t>
+              <a:t>방법론 — 커뮤니티 탐지 및 엔티티 해소</a:t>
             </a:r>
           </a:p>
         </p:txBody>
@@ -4163,7 +4163,7 @@
               </a:defRPr>
             </a:pPr>
             <a:r>
-              <a:t>Step 1: Embedding</a:t>
+              <a:t>1단계: 임베딩</a:t>
             </a:r>
           </a:p>
           <a:p>
@@ -4178,7 +4178,7 @@
               </a:defRPr>
             </a:pPr>
             <a:r>
-              <a:t>  - multilingual-e5-large -&gt; 1024-dim vector per entity</a:t>
+              <a:t>  - multilingual-e5-large -&gt; 엔티티별 1024차원 벡터 생성</a:t>
             </a:r>
           </a:p>
           <a:p>
@@ -4205,7 +4205,7 @@
               </a:defRPr>
             </a:pPr>
             <a:r>
-              <a:t>Step 2: Community Detection (GDS)</a:t>
+              <a:t>2단계: 커뮤니티 탐지 (GDS)</a:t>
             </a:r>
           </a:p>
           <a:p>
@@ -4220,7 +4220,7 @@
               </a:defRPr>
             </a:pPr>
             <a:r>
-              <a:t>  - KNN: cosine similarity &gt;= 0.95 -&gt; SIMILAR relationship</a:t>
+              <a:t>  - KNN: 코사인 유사도 &gt;= 0.95 -&gt; SIMILAR 관계 생성</a:t>
             </a:r>
           </a:p>
           <a:p>
@@ -4235,7 +4235,7 @@
               </a:defRPr>
             </a:pPr>
             <a:r>
-              <a:t>  - WCC: connected components -&gt; community ID</a:t>
+              <a:t>  - WCC: 연결 컴포넌트 -&gt; 커뮤니티 ID 부여</a:t>
             </a:r>
           </a:p>
           <a:p>
@@ -4262,7 +4262,7 @@
               </a:defRPr>
             </a:pPr>
             <a:r>
-              <a:t>Step 3: Entity Resolution</a:t>
+              <a:t>3단계: 엔티티 해소</a:t>
             </a:r>
           </a:p>
           <a:p>
@@ -4277,7 +4277,7 @@
               </a:defRPr>
             </a:pPr>
             <a:r>
-              <a:t>  - Candidate filtering: APOC text edit distance &lt;= 3</a:t>
+              <a:t>  - 후보 필터링: APOC 텍스트 편집거리 &lt;= 3</a:t>
             </a:r>
           </a:p>
           <a:p>
@@ -4292,7 +4292,7 @@
               </a:defRPr>
             </a:pPr>
             <a:r>
-              <a:t>  - Gemini structured output (Pydantic schema) for merge judgment</a:t>
+              <a:t>  - Gemini 구조화 출력(Pydantic 스키마)으로 병합 판정</a:t>
             </a:r>
           </a:p>
           <a:p>
@@ -4307,7 +4307,7 @@
               </a:defRPr>
             </a:pPr>
             <a:r>
-              <a:t>  - APOC mergeNodes for duplicate removal</a:t>
+              <a:t>  - APOC mergeNodes로 중복 노드 병합</a:t>
             </a:r>
           </a:p>
         </p:txBody>
@@ -4392,7 +4392,7 @@
               </a:defRPr>
             </a:pPr>
             <a:r>
-              <a:t>Results — Interactive Dashboard</a:t>
+              <a:t>결과 — 인터랙티브 대시보드</a:t>
             </a:r>
           </a:p>
         </p:txBody>
@@ -4430,7 +4430,7 @@
               </a:defRPr>
             </a:pPr>
             <a:r>
-              <a:t>- Pipeline control + graph visualization + real-time log in single dashboard</a:t>
+              <a:t>- 파이프라인 제어 + 그래프 시각화 + 실시간 로그를 단일 대시보드에 통합</a:t>
             </a:r>
           </a:p>
           <a:p>
@@ -4445,7 +4445,7 @@
               </a:defRPr>
             </a:pPr>
             <a:r>
-              <a:t>- SSE-based live log streaming, auto-refresh on pipeline completion</a:t>
+              <a:t>- SSE 기반 실시간 로그 스트리밍, 파이프라인 완료 시 그래프 자동 갱신</a:t>
             </a:r>
           </a:p>
           <a:p>
@@ -4460,7 +4460,7 @@
               </a:defRPr>
             </a:pPr>
             <a:r>
-              <a:t>- 5 layout algorithms, pan/zoom interaction</a:t>
+              <a:t>- 5종 레이아웃 알고리즘 전환, 팬/줌 인터랙션 지원</a:t>
             </a:r>
           </a:p>
         </p:txBody>
@@ -4546,7 +4546,7 @@
               </a:defRPr>
             </a:pPr>
             <a:r>
-              <a:t>Left: Full knowledge graph network view          Right: Entity relationship detail view</a:t>
+              <a:t>좌: 전체 지식 그래프 네트워크 뷰                    우: 엔티티 간 관계 상세 뷰</a:t>
             </a:r>
           </a:p>
         </p:txBody>
@@ -4607,7 +4607,7 @@
               </a:defRPr>
             </a:pPr>
             <a:r>
-              <a:t>Results — Pipeline Output</a:t>
+              <a:t>결과 — 파이프라인 산출물</a:t>
             </a:r>
           </a:p>
         </p:txBody>
@@ -4648,7 +4648,7 @@
                         </a:defRPr>
                       </a:pPr>
                       <a:r>
-                        <a:t>Item</a:t>
+                        <a:t>항목</a:t>
                       </a:r>
                     </a:p>
                   </a:txBody>
@@ -4671,7 +4671,7 @@
                         </a:defRPr>
                       </a:pPr>
                       <a:r>
-                        <a:t>Value</a:t>
+                        <a:t>값</a:t>
                       </a:r>
                     </a:p>
                   </a:txBody>
@@ -4696,7 +4696,7 @@
                         </a:defRPr>
                       </a:pPr>
                       <a:r>
-                        <a:t>Input Document</a:t>
+                        <a:t>입력 문서</a:t>
                       </a:r>
                     </a:p>
                   </a:txBody>
@@ -4719,7 +4719,7 @@
                         </a:defRPr>
                       </a:pPr>
                       <a:r>
-                        <a:t>EU AI Act (full text)</a:t>
+                        <a:t>EU AI Act 원문 (텍스트)</a:t>
                       </a:r>
                     </a:p>
                   </a:txBody>
@@ -4744,7 +4744,7 @@
                         </a:defRPr>
                       </a:pPr>
                       <a:r>
-                        <a:t>Chunking</a:t>
+                        <a:t>청킹</a:t>
                       </a:r>
                     </a:p>
                   </a:txBody>
@@ -4767,7 +4767,7 @@
                         </a:defRPr>
                       </a:pPr>
                       <a:r>
-                        <a:t>Qwen3 tokenizer, 350 tok / 75 overlap</a:t>
+                        <a:t>Qwen3 토크나이저, 350토큰 / 75 오버랩</a:t>
                       </a:r>
                     </a:p>
                   </a:txBody>
@@ -4792,7 +4792,7 @@
                         </a:defRPr>
                       </a:pPr>
                       <a:r>
-                        <a:t>Extraction Strategy</a:t>
+                        <a:t>추출 전략</a:t>
                       </a:r>
                     </a:p>
                   </a:txBody>
@@ -4815,7 +4815,7 @@
                         </a:defRPr>
                       </a:pPr>
                       <a:r>
-                        <a:t>vLLM primary + Gemini fallback</a:t>
+                        <a:t>vLLM 1차 추출 + Gemini 2차 폴백</a:t>
                       </a:r>
                     </a:p>
                   </a:txBody>
@@ -4840,7 +4840,7 @@
                         </a:defRPr>
                       </a:pPr>
                       <a:r>
-                        <a:t>Final Nodes</a:t>
+                        <a:t>최종 노드 수</a:t>
                       </a:r>
                     </a:p>
                   </a:txBody>
@@ -4863,7 +4863,7 @@
                         </a:defRPr>
                       </a:pPr>
                       <a:r>
-                        <a:t>475 (__Entity__)</a:t>
+                        <a:t>475개 (__Entity__)</a:t>
                       </a:r>
                     </a:p>
                   </a:txBody>
@@ -4888,7 +4888,7 @@
                         </a:defRPr>
                       </a:pPr>
                       <a:r>
-                        <a:t>Final Edges</a:t>
+                        <a:t>최종 엣지 수</a:t>
                       </a:r>
                     </a:p>
                   </a:txBody>
@@ -4911,7 +4911,7 @@
                         </a:defRPr>
                       </a:pPr>
                       <a:r>
-                        <a:t>500 (relationships)</a:t>
+                        <a:t>500개 (관계)</a:t>
                       </a:r>
                     </a:p>
                   </a:txBody>
@@ -4936,7 +4936,7 @@
                         </a:defRPr>
                       </a:pPr>
                       <a:r>
-                        <a:t>Entity Resolution</a:t>
+                        <a:t>엔티티 해소</a:t>
                       </a:r>
                     </a:p>
                   </a:txBody>
@@ -4959,7 +4959,7 @@
                         </a:defRPr>
                       </a:pPr>
                       <a:r>
-                        <a:t>KNN+WCC community detection -&gt; Gemini -&gt; APOC merge</a:t>
+                        <a:t>KNN+WCC 커뮤니티 탐지 -&gt; Gemini 판정 -&gt; APOC 병합</a:t>
                       </a:r>
                     </a:p>
                   </a:txBody>
@@ -5004,7 +5004,7 @@
               </a:defRPr>
             </a:pPr>
             <a:r>
-              <a:t>Key Achievements</a:t>
+              <a:t>주요 성과</a:t>
             </a:r>
           </a:p>
         </p:txBody>
@@ -5042,7 +5042,7 @@
               </a:defRPr>
             </a:pPr>
             <a:r>
-              <a:t>- Automated conversion of EU AI Act into structured knowledge graph</a:t>
+              <a:t>- EU AI Act를 구조화된 지식 그래프로 자동 변환</a:t>
             </a:r>
           </a:p>
           <a:p>
@@ -5057,7 +5057,7 @@
               </a:defRPr>
             </a:pPr>
             <a:r>
-              <a:t>- Dual-LLM strategy reduced extraction failure rate vs single model</a:t>
+              <a:t>- 이중 LLM 전략으로 단일 모델 대비 추출 실패율 감소</a:t>
             </a:r>
           </a:p>
           <a:p>
@@ -5072,7 +5072,7 @@
               </a:defRPr>
             </a:pPr>
             <a:r>
-              <a:t>- Community-based entity resolution removed duplicate nodes, improving graph quality</a:t>
+              <a:t>- 커뮤니티 기반 엔티티 해소로 중복 노드 제거, 그래프 품질 향상</a:t>
             </a:r>
           </a:p>
         </p:txBody>

</xml_diff>

<commit_message>
Apply KoPub돋움체 font to all slide text
Co-Authored-By: Claude Opus 4.6 <noreply@anthropic.com>
</commit_message>
<xml_diff>
--- a/docs/euAIKG_technical.pptx
+++ b/docs/euAIKG_technical.pptx
@@ -3128,6 +3128,7 @@
                 <a:solidFill>
                   <a:srgbClr val="1A1A2E"/>
                 </a:solidFill>
+                <a:latin typeface="KoPub돋움체 Bold"/>
               </a:defRPr>
             </a:pPr>
             <a:r>
@@ -3166,6 +3167,7 @@
                 <a:solidFill>
                   <a:srgbClr val="1A1A2E"/>
                 </a:solidFill>
+                <a:latin typeface="KoPub돋움체 Medium"/>
               </a:defRPr>
             </a:pPr>
             <a:r>
@@ -3181,6 +3183,7 @@
                 <a:solidFill>
                   <a:srgbClr val="1A1A2E"/>
                 </a:solidFill>
+                <a:latin typeface="KoPub돋움체 Medium"/>
               </a:defRPr>
             </a:pPr>
           </a:p>
@@ -3193,6 +3196,7 @@
                 <a:solidFill>
                   <a:srgbClr val="1A1A2E"/>
                 </a:solidFill>
+                <a:latin typeface="KoPub돋움체 Medium"/>
               </a:defRPr>
             </a:pPr>
             <a:r>
@@ -3208,6 +3212,7 @@
                 <a:solidFill>
                   <a:srgbClr val="1A1A2E"/>
                 </a:solidFill>
+                <a:latin typeface="KoPub돋움체 Medium"/>
               </a:defRPr>
             </a:pPr>
             <a:r>
@@ -3223,6 +3228,7 @@
                 <a:solidFill>
                   <a:srgbClr val="1A1A2E"/>
                 </a:solidFill>
+                <a:latin typeface="KoPub돋움체 Medium"/>
               </a:defRPr>
             </a:pPr>
             <a:r>
@@ -3308,6 +3314,7 @@
                 <a:solidFill>
                   <a:srgbClr val="1A1A2E"/>
                 </a:solidFill>
+                <a:latin typeface="KoPub돋움체 Bold"/>
               </a:defRPr>
             </a:pPr>
             <a:r>
@@ -3387,6 +3394,7 @@
                 <a:solidFill>
                   <a:srgbClr val="1E88E5"/>
                 </a:solidFill>
+                <a:latin typeface="KoPub돋움체 Bold"/>
               </a:defRPr>
             </a:pPr>
             <a:r>
@@ -3425,6 +3433,7 @@
                 <a:solidFill>
                   <a:srgbClr val="666666"/>
                 </a:solidFill>
+                <a:latin typeface="KoPub돋움체 Medium"/>
               </a:defRPr>
             </a:pPr>
             <a:r>
@@ -3440,6 +3449,7 @@
                 <a:solidFill>
                   <a:srgbClr val="666666"/>
                 </a:solidFill>
+                <a:latin typeface="KoPub돋움체 Medium"/>
               </a:defRPr>
             </a:pPr>
             <a:r>
@@ -3519,6 +3529,7 @@
                 <a:solidFill>
                   <a:srgbClr val="1E88E5"/>
                 </a:solidFill>
+                <a:latin typeface="KoPub돋움체 Bold"/>
               </a:defRPr>
             </a:pPr>
             <a:r>
@@ -3557,6 +3568,7 @@
                 <a:solidFill>
                   <a:srgbClr val="666666"/>
                 </a:solidFill>
+                <a:latin typeface="KoPub돋움체 Medium"/>
               </a:defRPr>
             </a:pPr>
             <a:r>
@@ -3572,6 +3584,7 @@
                 <a:solidFill>
                   <a:srgbClr val="666666"/>
                 </a:solidFill>
+                <a:latin typeface="KoPub돋움체 Medium"/>
               </a:defRPr>
             </a:pPr>
             <a:r>
@@ -3651,6 +3664,7 @@
                 <a:solidFill>
                   <a:srgbClr val="1E88E5"/>
                 </a:solidFill>
+                <a:latin typeface="KoPub돋움체 Bold"/>
               </a:defRPr>
             </a:pPr>
             <a:r>
@@ -3689,6 +3703,7 @@
                 <a:solidFill>
                   <a:srgbClr val="666666"/>
                 </a:solidFill>
+                <a:latin typeface="KoPub돋움체 Medium"/>
               </a:defRPr>
             </a:pPr>
             <a:r>
@@ -3704,6 +3719,7 @@
                 <a:solidFill>
                   <a:srgbClr val="666666"/>
                 </a:solidFill>
+                <a:latin typeface="KoPub돋움체 Medium"/>
               </a:defRPr>
             </a:pPr>
             <a:r>
@@ -3783,6 +3799,7 @@
                 <a:solidFill>
                   <a:srgbClr val="1E88E5"/>
                 </a:solidFill>
+                <a:latin typeface="KoPub돋움체 Bold"/>
               </a:defRPr>
             </a:pPr>
             <a:r>
@@ -3821,6 +3838,7 @@
                 <a:solidFill>
                   <a:srgbClr val="666666"/>
                 </a:solidFill>
+                <a:latin typeface="KoPub돋움체 Medium"/>
               </a:defRPr>
             </a:pPr>
             <a:r>
@@ -3836,6 +3854,7 @@
                 <a:solidFill>
                   <a:srgbClr val="666666"/>
                 </a:solidFill>
+                <a:latin typeface="KoPub돋움체 Medium"/>
               </a:defRPr>
             </a:pPr>
             <a:r>
@@ -3897,6 +3916,7 @@
                 <a:solidFill>
                   <a:srgbClr val="1A1A2E"/>
                 </a:solidFill>
+                <a:latin typeface="KoPub돋움체 Bold"/>
               </a:defRPr>
             </a:pPr>
             <a:r>
@@ -3935,6 +3955,7 @@
                 <a:solidFill>
                   <a:srgbClr val="1A1A2E"/>
                 </a:solidFill>
+                <a:latin typeface="KoPub돋움체 Medium"/>
               </a:defRPr>
             </a:pPr>
             <a:r>
@@ -3950,6 +3971,7 @@
                 <a:solidFill>
                   <a:srgbClr val="1A1A2E"/>
                 </a:solidFill>
+                <a:latin typeface="KoPub돋움체 Medium"/>
               </a:defRPr>
             </a:pPr>
             <a:r>
@@ -3965,6 +3987,7 @@
                 <a:solidFill>
                   <a:srgbClr val="1A1A2E"/>
                 </a:solidFill>
+                <a:latin typeface="KoPub돋움체 Medium"/>
               </a:defRPr>
             </a:pPr>
             <a:r>
@@ -3980,6 +4003,7 @@
                 <a:solidFill>
                   <a:srgbClr val="1A1A2E"/>
                 </a:solidFill>
+                <a:latin typeface="KoPub돋움체 Medium"/>
               </a:defRPr>
             </a:pPr>
             <a:r>
@@ -3995,6 +4019,7 @@
                 <a:solidFill>
                   <a:srgbClr val="1A1A2E"/>
                 </a:solidFill>
+                <a:latin typeface="KoPub돋움체 Medium"/>
               </a:defRPr>
             </a:pPr>
           </a:p>
@@ -4007,6 +4032,7 @@
                 <a:solidFill>
                   <a:srgbClr val="1A1A2E"/>
                 </a:solidFill>
+                <a:latin typeface="KoPub돋움체 Medium"/>
               </a:defRPr>
             </a:pPr>
             <a:r>
@@ -4022,6 +4048,7 @@
                 <a:solidFill>
                   <a:srgbClr val="1A1A2E"/>
                 </a:solidFill>
+                <a:latin typeface="KoPub돋움체 Medium"/>
               </a:defRPr>
             </a:pPr>
             <a:r>
@@ -4037,6 +4064,7 @@
                 <a:solidFill>
                   <a:srgbClr val="1A1A2E"/>
                 </a:solidFill>
+                <a:latin typeface="KoPub돋움체 Medium"/>
               </a:defRPr>
             </a:pPr>
             <a:r>
@@ -4122,6 +4150,7 @@
                 <a:solidFill>
                   <a:srgbClr val="1A1A2E"/>
                 </a:solidFill>
+                <a:latin typeface="KoPub돋움체 Bold"/>
               </a:defRPr>
             </a:pPr>
             <a:r>
@@ -4160,6 +4189,7 @@
                 <a:solidFill>
                   <a:srgbClr val="1A1A2E"/>
                 </a:solidFill>
+                <a:latin typeface="KoPub돋움체 Medium"/>
               </a:defRPr>
             </a:pPr>
             <a:r>
@@ -4175,6 +4205,7 @@
                 <a:solidFill>
                   <a:srgbClr val="1A1A2E"/>
                 </a:solidFill>
+                <a:latin typeface="KoPub돋움체 Medium"/>
               </a:defRPr>
             </a:pPr>
             <a:r>
@@ -4190,6 +4221,7 @@
                 <a:solidFill>
                   <a:srgbClr val="1A1A2E"/>
                 </a:solidFill>
+                <a:latin typeface="KoPub돋움체 Medium"/>
               </a:defRPr>
             </a:pPr>
           </a:p>
@@ -4202,6 +4234,7 @@
                 <a:solidFill>
                   <a:srgbClr val="1A1A2E"/>
                 </a:solidFill>
+                <a:latin typeface="KoPub돋움체 Medium"/>
               </a:defRPr>
             </a:pPr>
             <a:r>
@@ -4217,6 +4250,7 @@
                 <a:solidFill>
                   <a:srgbClr val="1A1A2E"/>
                 </a:solidFill>
+                <a:latin typeface="KoPub돋움체 Medium"/>
               </a:defRPr>
             </a:pPr>
             <a:r>
@@ -4232,6 +4266,7 @@
                 <a:solidFill>
                   <a:srgbClr val="1A1A2E"/>
                 </a:solidFill>
+                <a:latin typeface="KoPub돋움체 Medium"/>
               </a:defRPr>
             </a:pPr>
             <a:r>
@@ -4247,6 +4282,7 @@
                 <a:solidFill>
                   <a:srgbClr val="1A1A2E"/>
                 </a:solidFill>
+                <a:latin typeface="KoPub돋움체 Medium"/>
               </a:defRPr>
             </a:pPr>
           </a:p>
@@ -4259,6 +4295,7 @@
                 <a:solidFill>
                   <a:srgbClr val="1A1A2E"/>
                 </a:solidFill>
+                <a:latin typeface="KoPub돋움체 Medium"/>
               </a:defRPr>
             </a:pPr>
             <a:r>
@@ -4274,6 +4311,7 @@
                 <a:solidFill>
                   <a:srgbClr val="1A1A2E"/>
                 </a:solidFill>
+                <a:latin typeface="KoPub돋움체 Medium"/>
               </a:defRPr>
             </a:pPr>
             <a:r>
@@ -4289,6 +4327,7 @@
                 <a:solidFill>
                   <a:srgbClr val="1A1A2E"/>
                 </a:solidFill>
+                <a:latin typeface="KoPub돋움체 Medium"/>
               </a:defRPr>
             </a:pPr>
             <a:r>
@@ -4304,6 +4343,7 @@
                 <a:solidFill>
                   <a:srgbClr val="1A1A2E"/>
                 </a:solidFill>
+                <a:latin typeface="KoPub돋움체 Medium"/>
               </a:defRPr>
             </a:pPr>
             <a:r>
@@ -4389,6 +4429,7 @@
                 <a:solidFill>
                   <a:srgbClr val="1A1A2E"/>
                 </a:solidFill>
+                <a:latin typeface="KoPub돋움체 Bold"/>
               </a:defRPr>
             </a:pPr>
             <a:r>
@@ -4427,6 +4468,7 @@
                 <a:solidFill>
                   <a:srgbClr val="1A1A2E"/>
                 </a:solidFill>
+                <a:latin typeface="KoPub돋움체 Medium"/>
               </a:defRPr>
             </a:pPr>
             <a:r>
@@ -4442,6 +4484,7 @@
                 <a:solidFill>
                   <a:srgbClr val="1A1A2E"/>
                 </a:solidFill>
+                <a:latin typeface="KoPub돋움체 Medium"/>
               </a:defRPr>
             </a:pPr>
             <a:r>
@@ -4457,6 +4500,7 @@
                 <a:solidFill>
                   <a:srgbClr val="1A1A2E"/>
                 </a:solidFill>
+                <a:latin typeface="KoPub돋움체 Medium"/>
               </a:defRPr>
             </a:pPr>
             <a:r>
@@ -4543,6 +4587,7 @@
                 <a:solidFill>
                   <a:srgbClr val="666666"/>
                 </a:solidFill>
+                <a:latin typeface="KoPub돋움체 Medium"/>
               </a:defRPr>
             </a:pPr>
             <a:r>
@@ -4604,6 +4649,7 @@
                 <a:solidFill>
                   <a:srgbClr val="1A1A2E"/>
                 </a:solidFill>
+                <a:latin typeface="KoPub돋움체 Bold"/>
               </a:defRPr>
             </a:pPr>
             <a:r>
@@ -4645,6 +4691,7 @@
                           <a:solidFill>
                             <a:srgbClr val="FFFFFF"/>
                           </a:solidFill>
+                          <a:latin typeface="KoPub돋움체 Bold"/>
                         </a:defRPr>
                       </a:pPr>
                       <a:r>
@@ -4668,6 +4715,7 @@
                           <a:solidFill>
                             <a:srgbClr val="FFFFFF"/>
                           </a:solidFill>
+                          <a:latin typeface="KoPub돋움체 Bold"/>
                         </a:defRPr>
                       </a:pPr>
                       <a:r>
@@ -4693,6 +4741,7 @@
                           <a:solidFill>
                             <a:srgbClr val="1A1A2E"/>
                           </a:solidFill>
+                          <a:latin typeface="KoPub돋움체 Medium"/>
                         </a:defRPr>
                       </a:pPr>
                       <a:r>
@@ -4716,6 +4765,7 @@
                           <a:solidFill>
                             <a:srgbClr val="1A1A2E"/>
                           </a:solidFill>
+                          <a:latin typeface="KoPub돋움체 Medium"/>
                         </a:defRPr>
                       </a:pPr>
                       <a:r>
@@ -4741,6 +4791,7 @@
                           <a:solidFill>
                             <a:srgbClr val="1A1A2E"/>
                           </a:solidFill>
+                          <a:latin typeface="KoPub돋움체 Medium"/>
                         </a:defRPr>
                       </a:pPr>
                       <a:r>
@@ -4764,6 +4815,7 @@
                           <a:solidFill>
                             <a:srgbClr val="1A1A2E"/>
                           </a:solidFill>
+                          <a:latin typeface="KoPub돋움체 Medium"/>
                         </a:defRPr>
                       </a:pPr>
                       <a:r>
@@ -4789,6 +4841,7 @@
                           <a:solidFill>
                             <a:srgbClr val="1A1A2E"/>
                           </a:solidFill>
+                          <a:latin typeface="KoPub돋움체 Medium"/>
                         </a:defRPr>
                       </a:pPr>
                       <a:r>
@@ -4812,6 +4865,7 @@
                           <a:solidFill>
                             <a:srgbClr val="1A1A2E"/>
                           </a:solidFill>
+                          <a:latin typeface="KoPub돋움체 Medium"/>
                         </a:defRPr>
                       </a:pPr>
                       <a:r>
@@ -4837,6 +4891,7 @@
                           <a:solidFill>
                             <a:srgbClr val="1A1A2E"/>
                           </a:solidFill>
+                          <a:latin typeface="KoPub돋움체 Medium"/>
                         </a:defRPr>
                       </a:pPr>
                       <a:r>
@@ -4860,6 +4915,7 @@
                           <a:solidFill>
                             <a:srgbClr val="1A1A2E"/>
                           </a:solidFill>
+                          <a:latin typeface="KoPub돋움체 Medium"/>
                         </a:defRPr>
                       </a:pPr>
                       <a:r>
@@ -4885,6 +4941,7 @@
                           <a:solidFill>
                             <a:srgbClr val="1A1A2E"/>
                           </a:solidFill>
+                          <a:latin typeface="KoPub돋움체 Medium"/>
                         </a:defRPr>
                       </a:pPr>
                       <a:r>
@@ -4908,6 +4965,7 @@
                           <a:solidFill>
                             <a:srgbClr val="1A1A2E"/>
                           </a:solidFill>
+                          <a:latin typeface="KoPub돋움체 Medium"/>
                         </a:defRPr>
                       </a:pPr>
                       <a:r>
@@ -4933,6 +4991,7 @@
                           <a:solidFill>
                             <a:srgbClr val="1A1A2E"/>
                           </a:solidFill>
+                          <a:latin typeface="KoPub돋움체 Medium"/>
                         </a:defRPr>
                       </a:pPr>
                       <a:r>
@@ -4956,6 +5015,7 @@
                           <a:solidFill>
                             <a:srgbClr val="1A1A2E"/>
                           </a:solidFill>
+                          <a:latin typeface="KoPub돋움체 Medium"/>
                         </a:defRPr>
                       </a:pPr>
                       <a:r>
@@ -5001,6 +5061,7 @@
                 <a:solidFill>
                   <a:srgbClr val="1E88E5"/>
                 </a:solidFill>
+                <a:latin typeface="KoPub돋움체 Bold"/>
               </a:defRPr>
             </a:pPr>
             <a:r>
@@ -5039,6 +5100,7 @@
                 <a:solidFill>
                   <a:srgbClr val="1A1A2E"/>
                 </a:solidFill>
+                <a:latin typeface="KoPub돋움체 Medium"/>
               </a:defRPr>
             </a:pPr>
             <a:r>
@@ -5054,6 +5116,7 @@
                 <a:solidFill>
                   <a:srgbClr val="1A1A2E"/>
                 </a:solidFill>
+                <a:latin typeface="KoPub돋움체 Medium"/>
               </a:defRPr>
             </a:pPr>
             <a:r>
@@ -5069,6 +5132,7 @@
                 <a:solidFill>
                   <a:srgbClr val="1A1A2E"/>
                 </a:solidFill>
+                <a:latin typeface="KoPub돋움체 Medium"/>
               </a:defRPr>
             </a:pPr>
             <a:r>

</xml_diff>